<commit_message>
fix(core): audit and fix file reading, file generation, response limits, and e2e workflows
</commit_message>
<xml_diff>
--- a/backend/sample_files/sample.pptx
+++ b/backend/sample_files/sample.pptx
@@ -3088,6 +3088,48 @@
         <p:nvPr/>
       </p:nvGrpSpPr>
       <p:grpSpPr/>
+      <p:sp>
+        <p:nvSpPr>
+          <p:cNvPr id="2" name="Title 1"/>
+          <p:cNvSpPr>
+            <a:spLocks noGrp="1"/>
+          </p:cNvSpPr>
+          <p:nvPr>
+            <p:ph type="title"/>
+          </p:nvPr>
+        </p:nvSpPr>
+        <p:spPr/>
+        <p:txBody>
+          <a:bodyPr/>
+          <a:lstStyle/>
+          <a:p>
+            <a:r>
+              <a:t>Sample Presentation</a:t>
+            </a:r>
+          </a:p>
+        </p:txBody>
+      </p:sp>
+      <p:sp>
+        <p:nvSpPr>
+          <p:cNvPr id="3" name="Content Placeholder 2"/>
+          <p:cNvSpPr>
+            <a:spLocks noGrp="1"/>
+          </p:cNvSpPr>
+          <p:nvPr>
+            <p:ph idx="1"/>
+          </p:nvPr>
+        </p:nvSpPr>
+        <p:spPr/>
+        <p:txBody>
+          <a:bodyPr/>
+          <a:lstStyle/>
+          <a:p>
+            <a:r>
+              <a:t>This is sample PPTX bullet content for audit parsing.</a:t>
+            </a:r>
+          </a:p>
+        </p:txBody>
+      </p:sp>
     </p:spTree>
   </p:cSld>
   <p:clrMapOvr>

</xml_diff>